<commit_message>
fix(ws1): enforce true 13.333x7.5 widescreen layout to eliminate horizontal clipping
</commit_message>
<xml_diff>
--- a/slides/ws1-12slide-visual-deck.pptx
+++ b/slides/ws1-12slide-visual-deck.pptx
@@ -21,8 +21,8 @@
   <p:notesMasterIdLst>
     <p:notesMasterId r:id="rId14"/>
   </p:notesMasterIdLst>
-  <p:sldSz cx="9144000" cy="5143500"/>
-  <p:notesSz cx="5143500" cy="9144000"/>
+  <p:sldSz cx="12191695" cy="6858000"/>
+  <p:notesSz cx="6858000" cy="12191695"/>
   <p:defaultTextStyle>
     <a:lvl1pPr marL="0" algn="l" defTabSz="914400" rtl="0" eaLnBrk="1" latinLnBrk="0" hangingPunct="1">
       <a:defRPr sz="1800" kern="1200">
@@ -3068,12 +3068,12 @@
         </p:nvSpPr>
         <p:spPr>
           <a:xfrm>
-            <a:off x="5486400" y="2103120"/>
-            <a:ext cx="6126480" cy="1828800"/>
+            <a:off x="5303520" y="2011680"/>
+            <a:ext cx="6309360" cy="2011680"/>
           </a:xfrm>
           <a:prstGeom prst="roundRect">
             <a:avLst>
-              <a:gd name="adj" fmla="val 4000"/>
+              <a:gd name="adj" fmla="val 3636"/>
             </a:avLst>
           </a:prstGeom>
           <a:solidFill>
@@ -3095,8 +3095,8 @@
         </p:nvSpPr>
         <p:spPr>
           <a:xfrm>
-            <a:off x="5669280" y="2286000"/>
-            <a:ext cx="5760720" cy="320040"/>
+            <a:off x="5486400" y="2194560"/>
+            <a:ext cx="5943600" cy="320040"/>
           </a:xfrm>
           <a:prstGeom prst="rect">
             <a:avLst/>
@@ -3134,8 +3134,8 @@
         </p:nvSpPr>
         <p:spPr>
           <a:xfrm>
-            <a:off x="5669280" y="2651760"/>
-            <a:ext cx="5760720" cy="1097280"/>
+            <a:off x="5486400" y="2560320"/>
+            <a:ext cx="5943600" cy="1097280"/>
           </a:xfrm>
           <a:prstGeom prst="rect">
             <a:avLst/>
@@ -13121,7 +13121,7 @@
         <p:spPr>
           <a:xfrm>
             <a:off x="548640" y="868680"/>
-            <a:ext cx="8046720" cy="5486400"/>
+            <a:ext cx="7132320" cy="5394960"/>
           </a:xfrm>
           <a:prstGeom prst="rect">
             <a:avLst/>
@@ -13136,8 +13136,8 @@
         </p:nvSpPr>
         <p:spPr>
           <a:xfrm>
-            <a:off x="8778240" y="868680"/>
-            <a:ext cx="2864815" cy="1691640"/>
+            <a:off x="7955280" y="868680"/>
+            <a:ext cx="3657600" cy="1691640"/>
           </a:xfrm>
           <a:prstGeom prst="roundRect">
             <a:avLst>
@@ -13163,8 +13163,8 @@
         </p:nvSpPr>
         <p:spPr>
           <a:xfrm>
-            <a:off x="8961120" y="1005840"/>
-            <a:ext cx="2468880" cy="274320"/>
+            <a:off x="8138160" y="1005840"/>
+            <a:ext cx="3291840" cy="274320"/>
           </a:xfrm>
           <a:prstGeom prst="rect">
             <a:avLst/>
@@ -13202,8 +13202,8 @@
         </p:nvSpPr>
         <p:spPr>
           <a:xfrm>
-            <a:off x="8961120" y="1325880"/>
-            <a:ext cx="2468880" cy="1097280"/>
+            <a:off x="8138160" y="1325880"/>
+            <a:ext cx="3291840" cy="1097280"/>
           </a:xfrm>
           <a:prstGeom prst="rect">
             <a:avLst/>
@@ -13244,8 +13244,8 @@
         </p:nvSpPr>
         <p:spPr>
           <a:xfrm>
-            <a:off x="8778240" y="2743200"/>
-            <a:ext cx="2864815" cy="1691640"/>
+            <a:off x="7955280" y="2743200"/>
+            <a:ext cx="3657600" cy="1691640"/>
           </a:xfrm>
           <a:prstGeom prst="roundRect">
             <a:avLst>
@@ -13271,8 +13271,8 @@
         </p:nvSpPr>
         <p:spPr>
           <a:xfrm>
-            <a:off x="8961120" y="2880360"/>
-            <a:ext cx="2468880" cy="274320"/>
+            <a:off x="8138160" y="2880360"/>
+            <a:ext cx="3291840" cy="274320"/>
           </a:xfrm>
           <a:prstGeom prst="rect">
             <a:avLst/>
@@ -13310,8 +13310,8 @@
         </p:nvSpPr>
         <p:spPr>
           <a:xfrm>
-            <a:off x="8961120" y="3200400"/>
-            <a:ext cx="2468880" cy="1097280"/>
+            <a:off x="8138160" y="3200400"/>
+            <a:ext cx="3291840" cy="1097280"/>
           </a:xfrm>
           <a:prstGeom prst="rect">
             <a:avLst/>
@@ -13352,8 +13352,8 @@
         </p:nvSpPr>
         <p:spPr>
           <a:xfrm>
-            <a:off x="8778240" y="4617720"/>
-            <a:ext cx="2864815" cy="1691640"/>
+            <a:off x="7955280" y="4617720"/>
+            <a:ext cx="3657600" cy="1691640"/>
           </a:xfrm>
           <a:prstGeom prst="roundRect">
             <a:avLst>
@@ -13379,8 +13379,8 @@
         </p:nvSpPr>
         <p:spPr>
           <a:xfrm>
-            <a:off x="8961120" y="4754880"/>
-            <a:ext cx="2468880" cy="274320"/>
+            <a:off x="8138160" y="4754880"/>
+            <a:ext cx="3291840" cy="274320"/>
           </a:xfrm>
           <a:prstGeom prst="rect">
             <a:avLst/>
@@ -13418,8 +13418,8 @@
         </p:nvSpPr>
         <p:spPr>
           <a:xfrm>
-            <a:off x="8961120" y="5074920"/>
-            <a:ext cx="2468880" cy="1097280"/>
+            <a:off x="8138160" y="5074920"/>
+            <a:ext cx="3291840" cy="1097280"/>
           </a:xfrm>
           <a:prstGeom prst="rect">
             <a:avLst/>

</xml_diff>

<commit_message>
fix(ws1): mathematically preserve exact native aspect ratios for diagrams and Retina UI screenshots
</commit_message>
<xml_diff>
--- a/slides/ws1-12slide-visual-deck.pptx
+++ b/slides/ws1-12slide-visual-deck.pptx
@@ -13120,8 +13120,8 @@
         </p:blipFill>
         <p:spPr>
           <a:xfrm>
-            <a:off x="548640" y="868680"/>
-            <a:ext cx="7132320" cy="5394960"/>
+            <a:off x="731520" y="868680"/>
+            <a:ext cx="4590288" cy="5394960"/>
           </a:xfrm>
           <a:prstGeom prst="rect">
             <a:avLst/>
@@ -13136,8 +13136,8 @@
         </p:nvSpPr>
         <p:spPr>
           <a:xfrm>
-            <a:off x="7955280" y="868680"/>
-            <a:ext cx="3657600" cy="1691640"/>
+            <a:off x="5760720" y="868680"/>
+            <a:ext cx="5852160" cy="1691640"/>
           </a:xfrm>
           <a:prstGeom prst="roundRect">
             <a:avLst>
@@ -13163,24 +13163,24 @@
         </p:nvSpPr>
         <p:spPr>
           <a:xfrm>
-            <a:off x="8138160" y="1005840"/>
-            <a:ext cx="3291840" cy="274320"/>
-          </a:xfrm>
-          <a:prstGeom prst="rect">
-            <a:avLst/>
-          </a:prstGeom>
-          <a:noFill/>
-          <a:ln/>
-        </p:spPr>
-        <p:txBody>
-          <a:bodyPr wrap="square" rtlCol="0" anchor="ctr"/>
-          <a:lstStyle/>
-          <a:p>
-            <a:pPr indent="0" marL="0">
-              <a:buNone/>
-            </a:pPr>
-            <a:r>
-              <a:rPr lang="en-US" sz="1050" b="1" dirty="0">
+            <a:off x="5989320" y="1005840"/>
+            <a:ext cx="5394960" cy="292608"/>
+          </a:xfrm>
+          <a:prstGeom prst="rect">
+            <a:avLst/>
+          </a:prstGeom>
+          <a:noFill/>
+          <a:ln/>
+        </p:spPr>
+        <p:txBody>
+          <a:bodyPr wrap="square" rtlCol="0" anchor="ctr"/>
+          <a:lstStyle/>
+          <a:p>
+            <a:pPr indent="0" marL="0">
+              <a:buNone/>
+            </a:pPr>
+            <a:r>
+              <a:rPr lang="en-US" sz="1100" b="1" dirty="0">
                 <a:solidFill>
                   <a:srgbClr val="1A73E8"/>
                 </a:solidFill>
@@ -13188,9 +13188,9 @@
                 <a:ea typeface="Google Sans" pitchFamily="34" charset="-122"/>
                 <a:cs typeface="Google Sans" pitchFamily="34" charset="-120"/>
               </a:rPr>
-              <a:t>ROUTING HUB</a:t>
-            </a:r>
-            <a:endParaRPr lang="en-US" sz="1050" dirty="0"/>
+              <a:t>ROUTING HUB (HOP 1 PEP)</a:t>
+            </a:r>
+            <a:endParaRPr lang="en-US" sz="1100" dirty="0"/>
           </a:p>
         </p:txBody>
       </p:sp>
@@ -13202,8 +13202,8 @@
         </p:nvSpPr>
         <p:spPr>
           <a:xfrm>
-            <a:off x="8138160" y="1325880"/>
-            <a:ext cx="3291840" cy="1097280"/>
+            <a:off x="5989320" y="1344168"/>
+            <a:ext cx="5394960" cy="1097280"/>
           </a:xfrm>
           <a:prstGeom prst="rect">
             <a:avLst/>
@@ -13217,12 +13217,12 @@
           <a:p>
             <a:pPr indent="0" marL="0">
               <a:lnSpc>
-                <a:spcPct val="120000"/>
+                <a:spcPct val="125000"/>
               </a:lnSpc>
               <a:buNone/>
             </a:pPr>
             <a:r>
-              <a:rPr lang="en-US" sz="900" dirty="0">
+              <a:rPr lang="en-US" sz="950" dirty="0">
                 <a:solidFill>
                   <a:srgbClr val="202124"/>
                 </a:solidFill>
@@ -13230,9 +13230,9 @@
                 <a:ea typeface="Roboto" pitchFamily="34" charset="-122"/>
                 <a:cs typeface="Roboto" pitchFamily="34" charset="-120"/>
               </a:rPr>
-              <a:t>Central ingress layer running Cloud Armor L7 WAF and Identity-Aware Proxy to strip untrusted caller headers.</a:t>
-            </a:r>
-            <a:endParaRPr lang="en-US" sz="900" dirty="0"/>
+              <a:t>Central ingress layer running Cloud Armor L7 WAF and Identity-Aware Proxy. Strips client-supplied X-Tenant-ID headers and performs IAM STS token exchange to mint an ECDSA P-256 signed TenantContext in &lt;0.15ms.</a:t>
+            </a:r>
+            <a:endParaRPr lang="en-US" sz="950" dirty="0"/>
           </a:p>
         </p:txBody>
       </p:sp>
@@ -13244,8 +13244,8 @@
         </p:nvSpPr>
         <p:spPr>
           <a:xfrm>
-            <a:off x="7955280" y="2743200"/>
-            <a:ext cx="3657600" cy="1691640"/>
+            <a:off x="5760720" y="2697480"/>
+            <a:ext cx="5852160" cy="1691640"/>
           </a:xfrm>
           <a:prstGeom prst="roundRect">
             <a:avLst>
@@ -13271,24 +13271,24 @@
         </p:nvSpPr>
         <p:spPr>
           <a:xfrm>
-            <a:off x="8138160" y="2880360"/>
-            <a:ext cx="3291840" cy="274320"/>
-          </a:xfrm>
-          <a:prstGeom prst="rect">
-            <a:avLst/>
-          </a:prstGeom>
-          <a:noFill/>
-          <a:ln/>
-        </p:spPr>
-        <p:txBody>
-          <a:bodyPr wrap="square" rtlCol="0" anchor="ctr"/>
-          <a:lstStyle/>
-          <a:p>
-            <a:pPr indent="0" marL="0">
-              <a:buNone/>
-            </a:pPr>
-            <a:r>
-              <a:rPr lang="en-US" sz="1050" b="1" dirty="0">
+            <a:off x="5989320" y="2834640"/>
+            <a:ext cx="5394960" cy="292608"/>
+          </a:xfrm>
+          <a:prstGeom prst="rect">
+            <a:avLst/>
+          </a:prstGeom>
+          <a:noFill/>
+          <a:ln/>
+        </p:spPr>
+        <p:txBody>
+          <a:bodyPr wrap="square" rtlCol="0" anchor="ctr"/>
+          <a:lstStyle/>
+          <a:p>
+            <a:pPr indent="0" marL="0">
+              <a:buNone/>
+            </a:pPr>
+            <a:r>
+              <a:rPr lang="en-US" sz="1100" b="1" dirty="0">
                 <a:solidFill>
                   <a:srgbClr val="FBBC04"/>
                 </a:solidFill>
@@ -13296,9 +13296,9 @@
                 <a:ea typeface="Google Sans" pitchFamily="34" charset="-122"/>
                 <a:cs typeface="Google Sans" pitchFamily="34" charset="-120"/>
               </a:rPr>
-              <a:t>GOVERNANCE HUB</a:t>
-            </a:r>
-            <a:endParaRPr lang="en-US" sz="1050" dirty="0"/>
+              <a:t>GOVERNANCE HUB (HOP 2 PDP)</a:t>
+            </a:r>
+            <a:endParaRPr lang="en-US" sz="1100" dirty="0"/>
           </a:p>
         </p:txBody>
       </p:sp>
@@ -13310,8 +13310,8 @@
         </p:nvSpPr>
         <p:spPr>
           <a:xfrm>
-            <a:off x="8138160" y="3200400"/>
-            <a:ext cx="3291840" cy="1097280"/>
+            <a:off x="5989320" y="3172968"/>
+            <a:ext cx="5394960" cy="1097280"/>
           </a:xfrm>
           <a:prstGeom prst="rect">
             <a:avLst/>
@@ -13325,12 +13325,12 @@
           <a:p>
             <a:pPr indent="0" marL="0">
               <a:lnSpc>
-                <a:spcPct val="120000"/>
+                <a:spcPct val="125000"/>
               </a:lnSpc>
               <a:buNone/>
             </a:pPr>
             <a:r>
-              <a:rPr lang="en-US" sz="900" dirty="0">
+              <a:rPr lang="en-US" sz="950" dirty="0">
                 <a:solidFill>
                   <a:srgbClr val="202124"/>
                 </a:solidFill>
@@ -13338,9 +13338,9 @@
                 <a:ea typeface="Roboto" pitchFamily="34" charset="-122"/>
                 <a:cs typeface="Roboto" pitchFamily="34" charset="-120"/>
               </a:rPr>
-              <a:t>Vertex AI Agent Engine catalog and Cloud KMS verifying tenant capability tokens in &lt;0.15ms.</a:t>
-            </a:r>
-            <a:endParaRPr lang="en-US" sz="900" dirty="0"/>
+              <a:t>Discovery Engine and Vertex AI Agent Engine catalog. Evaluates tenant capability grants and prunes unauthorized tools from the system prompt via ADK before_agent_callback, preventing confused deputy attacks.</a:t>
+            </a:r>
+            <a:endParaRPr lang="en-US" sz="950" dirty="0"/>
           </a:p>
         </p:txBody>
       </p:sp>
@@ -13352,8 +13352,8 @@
         </p:nvSpPr>
         <p:spPr>
           <a:xfrm>
-            <a:off x="7955280" y="4617720"/>
-            <a:ext cx="3657600" cy="1691640"/>
+            <a:off x="5760720" y="4526280"/>
+            <a:ext cx="5852160" cy="1691640"/>
           </a:xfrm>
           <a:prstGeom prst="roundRect">
             <a:avLst>
@@ -13379,24 +13379,24 @@
         </p:nvSpPr>
         <p:spPr>
           <a:xfrm>
-            <a:off x="8138160" y="4754880"/>
-            <a:ext cx="3291840" cy="274320"/>
-          </a:xfrm>
-          <a:prstGeom prst="rect">
-            <a:avLst/>
-          </a:prstGeom>
-          <a:noFill/>
-          <a:ln/>
-        </p:spPr>
-        <p:txBody>
-          <a:bodyPr wrap="square" rtlCol="0" anchor="ctr"/>
-          <a:lstStyle/>
-          <a:p>
-            <a:pPr indent="0" marL="0">
-              <a:buNone/>
-            </a:pPr>
-            <a:r>
-              <a:rPr lang="en-US" sz="1050" b="1" dirty="0">
+            <a:off x="5989320" y="4663440"/>
+            <a:ext cx="5394960" cy="292608"/>
+          </a:xfrm>
+          <a:prstGeom prst="rect">
+            <a:avLst/>
+          </a:prstGeom>
+          <a:noFill/>
+          <a:ln/>
+        </p:spPr>
+        <p:txBody>
+          <a:bodyPr wrap="square" rtlCol="0" anchor="ctr"/>
+          <a:lstStyle/>
+          <a:p>
+            <a:pPr indent="0" marL="0">
+              <a:buNone/>
+            </a:pPr>
+            <a:r>
+              <a:rPr lang="en-US" sz="1100" b="1" dirty="0">
                 <a:solidFill>
                   <a:srgbClr val="34A853"/>
                 </a:solidFill>
@@ -13404,9 +13404,9 @@
                 <a:ea typeface="Google Sans" pitchFamily="34" charset="-122"/>
                 <a:cs typeface="Google Sans" pitchFamily="34" charset="-120"/>
               </a:rPr>
-              <a:t>SPOKE ISOLATION</a:t>
-            </a:r>
-            <a:endParaRPr lang="en-US" sz="1050" dirty="0"/>
+              <a:t>SPOKE ISOLATION (PSC TRANSIT)</a:t>
+            </a:r>
+            <a:endParaRPr lang="en-US" sz="1100" dirty="0"/>
           </a:p>
         </p:txBody>
       </p:sp>
@@ -13418,8 +13418,8 @@
         </p:nvSpPr>
         <p:spPr>
           <a:xfrm>
-            <a:off x="8138160" y="5074920"/>
-            <a:ext cx="3291840" cy="1097280"/>
+            <a:off x="5989320" y="5001768"/>
+            <a:ext cx="5394960" cy="1097280"/>
           </a:xfrm>
           <a:prstGeom prst="rect">
             <a:avLst/>
@@ -13433,12 +13433,12 @@
           <a:p>
             <a:pPr indent="0" marL="0">
               <a:lnSpc>
-                <a:spcPct val="120000"/>
+                <a:spcPct val="125000"/>
               </a:lnSpc>
               <a:buNone/>
             </a:pPr>
             <a:r>
-              <a:rPr lang="en-US" sz="900" dirty="0">
+              <a:rPr lang="en-US" sz="950" dirty="0">
                 <a:solidFill>
                   <a:srgbClr val="202124"/>
                 </a:solidFill>
@@ -13446,9 +13446,9 @@
                 <a:ea typeface="Roboto" pitchFamily="34" charset="-122"/>
                 <a:cs typeface="Roboto" pitchFamily="34" charset="-120"/>
               </a:rPr>
-              <a:t>PSC endpoints establishing zero-trust private channels into customer VPCs with zero public egress.</a:t>
-            </a:r>
-            <a:endParaRPr lang="en-US" sz="900" dirty="0"/>
+              <a:t>Private Service Connect endpoints establish zero-trust, unidirectional private channels into customer-owned VPCs. Completely blocks 0.0.0.0/0 public internet egress for sovereign data lake access.</a:t>
+            </a:r>
+            <a:endParaRPr lang="en-US" sz="950" dirty="0"/>
           </a:p>
         </p:txBody>
       </p:sp>
@@ -17455,7 +17455,7 @@
         <p:spPr>
           <a:xfrm>
             <a:off x="548640" y="1234440"/>
-            <a:ext cx="5212080" cy="3840480"/>
+            <a:ext cx="5303520" cy="3314700"/>
           </a:xfrm>
           <a:prstGeom prst="rect">
             <a:avLst/>
@@ -17478,8 +17478,8 @@
         </p:blipFill>
         <p:spPr>
           <a:xfrm>
-            <a:off x="6430975" y="1234440"/>
-            <a:ext cx="5212080" cy="3840480"/>
+            <a:off x="6339535" y="1234440"/>
+            <a:ext cx="5303520" cy="3314700"/>
           </a:xfrm>
           <a:prstGeom prst="rect">
             <a:avLst/>
@@ -17555,7 +17555,7 @@
         </p:nvSpPr>
         <p:spPr>
           <a:xfrm>
-            <a:off x="6613855" y="1417320"/>
+            <a:off x="6522415" y="1417320"/>
             <a:ext cx="2926080" cy="365760"/>
           </a:xfrm>
           <a:prstGeom prst="roundRect">
@@ -17577,7 +17577,7 @@
         </p:nvSpPr>
         <p:spPr>
           <a:xfrm>
-            <a:off x="6613855" y="1417320"/>
+            <a:off x="6522415" y="1417320"/>
             <a:ext cx="2926080" cy="365760"/>
           </a:xfrm>
           <a:prstGeom prst="rect">
@@ -17616,12 +17616,12 @@
         </p:nvSpPr>
         <p:spPr>
           <a:xfrm>
-            <a:off x="548640" y="5257800"/>
-            <a:ext cx="11094415" cy="1051560"/>
+            <a:off x="548640" y="4754880"/>
+            <a:ext cx="11094415" cy="1508760"/>
           </a:xfrm>
           <a:prstGeom prst="roundRect">
             <a:avLst>
-              <a:gd name="adj" fmla="val 6957"/>
+              <a:gd name="adj" fmla="val 4848"/>
             </a:avLst>
           </a:prstGeom>
           <a:solidFill>
@@ -17643,8 +17643,8 @@
         </p:nvSpPr>
         <p:spPr>
           <a:xfrm>
-            <a:off x="822960" y="5394960"/>
-            <a:ext cx="10515600" cy="274320"/>
+            <a:off x="822960" y="4892040"/>
+            <a:ext cx="10515600" cy="320040"/>
           </a:xfrm>
           <a:prstGeom prst="rect">
             <a:avLst/>
@@ -17682,8 +17682,8 @@
         </p:nvSpPr>
         <p:spPr>
           <a:xfrm>
-            <a:off x="822960" y="5715000"/>
-            <a:ext cx="10515600" cy="502920"/>
+            <a:off x="822960" y="5257800"/>
+            <a:ext cx="10515600" cy="868680"/>
           </a:xfrm>
           <a:prstGeom prst="rect">
             <a:avLst/>
@@ -17697,7 +17697,7 @@
           <a:p>
             <a:pPr indent="0" marL="0">
               <a:lnSpc>
-                <a:spcPct val="120000"/>
+                <a:spcPct val="125000"/>
               </a:lnSpc>
               <a:buNone/>
             </a:pPr>

</xml_diff>